<commit_message>
feat(dom): add accessible HTML and SVG backend (#10)
</commit_message>
<xml_diff>
--- a/fixtures/render/basic.pptx
+++ b/fixtures/render/basic.pptx
@@ -126,7 +126,9 @@
         </p:grpSpPr>
         <p:sp>
           <p:nvSpPr>
-            <p:cNvPr id="2" name="Title"/>
+            <p:cNvPr id="2" name="Title" descr="Quarterly report title">
+              <a:hlinkClick r:id="rLink"/>
+            </p:cNvPr>
             <p:nvPr>
               <p:ph type="title" idx="1"/>
             </p:nvPr>
@@ -145,7 +147,7 @@
       </p:grpSp>
       <p:pic>
         <p:nvPicPr>
-          <p:cNvPr id="3" name="Photo"/>
+          <p:cNvPr id="3" name="Photo" descr="Quarterly report photo"/>
         </p:nvPicPr>
         <p:spPr>
           <a:xfrm>

</xml_diff>

<commit_message>
feat(pml): add tables charts and advanced capability policy (#11)
</commit_message>
<xml_diff>
--- a/fixtures/render/basic.pptx
+++ b/fixtures/render/basic.pptx
@@ -7,6 +7,67 @@
   </p:sldIdLst>
   <p:sldSz cx="12192000" cy="6858000"/>
 </p:presentation>
+</file>
+
+<file path=ppt/charts/chart1.xml><?xml version="1.0" encoding="utf-8"?>
+<c:chartSpace xmlns:c="http://schemas.openxmlformats.org/drawingml/2006/chart" xmlns:r="http://schemas.openxmlformats.org/officeDocument/2006/relationships">
+  <c:chart>
+    <c:plotArea>
+      <c:barChart>
+        <c:barDir val="col"/>
+        <c:ser>
+          <c:tx>
+            <c:strRef>
+              <c:f>Sheet1!$B$1</c:f>
+              <c:strCache>
+                <c:ptCount val="1"/>
+                <c:pt idx="0">
+                  <c:v>Sales</c:v>
+                </c:pt>
+              </c:strCache>
+            </c:strRef>
+          </c:tx>
+          <c:cat>
+            <c:strRef>
+              <c:f>Sheet1!$A$2:$A$4</c:f>
+              <c:strCache>
+                <c:ptCount val="3"/>
+                <c:pt idx="0">
+                  <c:v>Q1</c:v>
+                </c:pt>
+                <c:pt idx="1">
+                  <c:v>Q2</c:v>
+                </c:pt>
+                <c:pt idx="2">
+                  <c:v>Q3</c:v>
+                </c:pt>
+              </c:strCache>
+            </c:strRef>
+          </c:cat>
+          <c:val>
+            <c:numRef>
+              <c:f>Sheet1!$B$2:$B$4</c:f>
+              <c:numCache>
+                <c:formatCode>General</c:formatCode>
+                <c:ptCount val="3"/>
+                <c:pt idx="0">
+                  <c:v>42</c:v>
+                </c:pt>
+                <c:pt idx="1">
+                  <c:v>64</c:v>
+                </c:pt>
+                <c:pt idx="2">
+                  <c:v>53</c:v>
+                </c:pt>
+              </c:numCache>
+            </c:numRef>
+          </c:val>
+        </c:ser>
+      </c:barChart>
+    </c:plotArea>
+  </c:chart>
+  <c:externalData r:id="rWorkbook"/>
+</c:chartSpace>
 </file>
 
 <file path=ppt/slideLayouts/slideLayout1.xml><?xml version="1.0" encoding="utf-8"?>
@@ -183,7 +244,7 @@
 </file>
 
 <file path=ppt/slides/slide2.xml><?xml version="1.0" encoding="utf-8"?>
-<p:sld xmlns:p="http://schemas.openxmlformats.org/presentationml/2006/main" xmlns:a="http://schemas.openxmlformats.org/drawingml/2006/main">
+<p:sld xmlns:p="http://schemas.openxmlformats.org/presentationml/2006/main" xmlns:a="http://schemas.openxmlformats.org/drawingml/2006/main" xmlns:c="http://schemas.openxmlformats.org/drawingml/2006/chart" xmlns:dgm="http://schemas.openxmlformats.org/drawingml/2006/diagram" xmlns:r="http://schemas.openxmlformats.org/officeDocument/2006/relationships">
   <p:cSld>
     <p:spTree>
       <p:sp>
@@ -199,10 +260,112 @@
           <a:solidFill>
             <a:schemeClr val="accent1"/>
           </a:solidFill>
+          <a:sp3d/>
         </p:spPr>
       </p:sp>
+      <p:graphicFrame>
+        <p:nvGraphicFramePr>
+          <p:cNvPr id="6" name="Sales Table" descr="Quarterly sales table"/>
+        </p:nvGraphicFramePr>
+        <p:xfrm>
+          <a:off x="500000" y="500000"/>
+          <a:ext cx="5000000" cy="2500000"/>
+        </p:xfrm>
+        <a:graphic>
+          <a:graphicData uri="http://schemas.openxmlformats.org/drawingml/2006/table">
+            <a:tbl>
+              <a:tblGrid>
+                <a:gridCol w="2500000"/>
+                <a:gridCol w="2500000"/>
+              </a:tblGrid>
+              <a:tr h="1000000">
+                <a:tc>
+                  <a:txBody>
+                    <a:p>
+                      <a:r>
+                        <a:t>Quarter</a:t>
+                      </a:r>
+                    </a:p>
+                  </a:txBody>
+                  <a:tcPr>
+                    <a:solidFill>
+                      <a:srgbClr val="D9EAF7"/>
+                    </a:solidFill>
+                  </a:tcPr>
+                </a:tc>
+                <a:tc>
+                  <a:txBody>
+                    <a:p>
+                      <a:r>
+                        <a:t>Sales</a:t>
+                      </a:r>
+                    </a:p>
+                  </a:txBody>
+                </a:tc>
+              </a:tr>
+              <a:tr h="1500000">
+                <a:tc>
+                  <a:txBody>
+                    <a:p>
+                      <a:r>
+                        <a:t>Q1</a:t>
+                      </a:r>
+                    </a:p>
+                  </a:txBody>
+                </a:tc>
+                <a:tc>
+                  <a:txBody>
+                    <a:p>
+                      <a:r>
+                        <a:t>42</a:t>
+                      </a:r>
+                    </a:p>
+                  </a:txBody>
+                </a:tc>
+              </a:tr>
+            </a:tbl>
+          </a:graphicData>
+        </a:graphic>
+      </p:graphicFrame>
+      <p:graphicFrame>
+        <p:nvGraphicFramePr>
+          <p:cNvPr id="7" name="Sales Chart" descr="Quarterly sales chart"/>
+        </p:nvGraphicFramePr>
+        <p:xfrm>
+          <a:off x="6000000" y="500000"/>
+          <a:ext cx="5500000" cy="4000000"/>
+        </p:xfrm>
+        <a:graphic>
+          <a:graphicData uri="http://schemas.openxmlformats.org/drawingml/2006/chart">
+            <c:chart r:id="rChart"/>
+          </a:graphicData>
+        </a:graphic>
+      </p:graphicFrame>
+      <p:graphicFrame>
+        <p:nvGraphicFramePr>
+          <p:cNvPr id="8" name="SmartArt"/>
+        </p:nvGraphicFramePr>
+        <a:graphic>
+          <a:graphicData uri="http://schemas.openxmlformats.org/drawingml/2006/diagram">
+            <dgm:relIds r:dm="rDiagram"/>
+          </a:graphicData>
+        </a:graphic>
+      </p:graphicFrame>
+      <p:pic>
+        <p:nvPicPr>
+          <p:cNvPr id="9" name="Metafile"/>
+        </p:nvPicPr>
+        <p:spPr/>
+        <p:blipFill>
+          <a:blip r:embed="rEmf"/>
+        </p:blipFill>
+      </p:pic>
     </p:spTree>
   </p:cSld>
+  <p:transition/>
+  <p:timing>
+    <p:tnLst/>
+  </p:timing>
 </p:sld>
 </file>
 

</xml_diff>

<commit_message>
feat: render EMF and WMF previews in browsers
</commit_message>
<xml_diff>
--- a/fixtures/render/basic.pptx
+++ b/fixtures/render/basic.pptx
@@ -355,7 +355,12 @@
         <p:nvPicPr>
           <p:cNvPr id="9" name="Metafile"/>
         </p:nvPicPr>
-        <p:spPr/>
+        <p:spPr>
+          <a:xfrm>
+            <a:off x="8500000" y="4500000"/>
+            <a:ext cx="2500000" cy="1800000"/>
+          </a:xfrm>
+        </p:spPr>
         <p:blipFill>
           <a:blip r:embed="rEmf"/>
         </p:blipFill>

</xml_diff>

<commit_message>
feat: ship WPDL v4 render fidelity
</commit_message>
<xml_diff>
--- a/fixtures/render/basic.pptx
+++ b/fixtures/render/basic.pptx
@@ -198,9 +198,22 @@
             <a:prstGeom prst="rect"/>
           </p:spPr>
           <p:txBody>
+            <a:bodyPr anchor="ctr" wrap="square">
+              <a:normAutofit/>
+            </a:bodyPr>
             <a:p>
+              <a:pPr algn="ctr"/>
               <a:r>
-                <a:t>Actual title</a:t>
+                <a:rPr sz="2800" b="1">
+                  <a:latin typeface="Arial"/>
+                </a:rPr>
+                <a:t>Actual </a:t>
+              </a:r>
+              <a:r>
+                <a:rPr sz="2800" i="1">
+                  <a:ea typeface="Arial"/>
+                </a:rPr>
+                <a:t>title</a:t>
               </a:r>
             </a:p>
           </p:txBody>
@@ -227,10 +240,50 @@
         </p:nvSpPr>
         <p:spPr>
           <a:xfrm>
-            <a:off x="0" y="0"/>
-            <a:ext cx="10" cy="10"/>
-          </a:xfrm>
-          <a:custGeom/>
+            <a:off x="8000000" y="1000000"/>
+            <a:ext cx="2000000" cy="1600000"/>
+          </a:xfrm>
+          <a:custGeom>
+            <a:pathLst>
+              <a:path w="100" h="100">
+                <a:moveTo>
+                  <a:pt x="0" y="100"/>
+                </a:moveTo>
+                <a:lnTo>
+                  <a:pt x="50" y="0"/>
+                </a:lnTo>
+                <a:lnTo>
+                  <a:pt x="100" y="100"/>
+                </a:lnTo>
+                <a:close/>
+              </a:path>
+            </a:pathLst>
+          </a:custGeom>
+          <a:gradFill>
+            <a:gsLst>
+              <a:gs pos="0">
+                <a:srgbClr val="FFAA00"/>
+              </a:gs>
+              <a:gs pos="100000">
+                <a:srgbClr val="AA00FF"/>
+              </a:gs>
+            </a:gsLst>
+            <a:lin ang="5400000"/>
+          </a:gradFill>
+          <a:ln w="19050">
+            <a:solidFill>
+              <a:srgbClr val="222222"/>
+            </a:solidFill>
+            <a:headEnd type="triangle"/>
+            <a:tailEnd type="diamond"/>
+          </a:ln>
+          <a:effectLst>
+            <a:outerShdw blurRad="63500" dist="63500" dir="2700000">
+              <a:srgbClr val="333333">
+                <a:alpha val="50000"/>
+              </a:srgbClr>
+            </a:outerShdw>
+          </a:effectLst>
         </p:spPr>
       </p:sp>
       <p:graphicFrame>

</xml_diff>

<commit_message>
feat: ship WPDL v4 render fidelity (#25)
</commit_message>
<xml_diff>
--- a/fixtures/render/basic.pptx
+++ b/fixtures/render/basic.pptx
@@ -198,9 +198,22 @@
             <a:prstGeom prst="rect"/>
           </p:spPr>
           <p:txBody>
+            <a:bodyPr anchor="ctr" wrap="square">
+              <a:normAutofit/>
+            </a:bodyPr>
             <a:p>
+              <a:pPr algn="ctr"/>
               <a:r>
-                <a:t>Actual title</a:t>
+                <a:rPr sz="2800" b="1">
+                  <a:latin typeface="Arial"/>
+                </a:rPr>
+                <a:t>Actual </a:t>
+              </a:r>
+              <a:r>
+                <a:rPr sz="2800" i="1">
+                  <a:ea typeface="Arial"/>
+                </a:rPr>
+                <a:t>title</a:t>
               </a:r>
             </a:p>
           </p:txBody>
@@ -227,10 +240,50 @@
         </p:nvSpPr>
         <p:spPr>
           <a:xfrm>
-            <a:off x="0" y="0"/>
-            <a:ext cx="10" cy="10"/>
-          </a:xfrm>
-          <a:custGeom/>
+            <a:off x="8000000" y="1000000"/>
+            <a:ext cx="2000000" cy="1600000"/>
+          </a:xfrm>
+          <a:custGeom>
+            <a:pathLst>
+              <a:path w="100" h="100">
+                <a:moveTo>
+                  <a:pt x="0" y="100"/>
+                </a:moveTo>
+                <a:lnTo>
+                  <a:pt x="50" y="0"/>
+                </a:lnTo>
+                <a:lnTo>
+                  <a:pt x="100" y="100"/>
+                </a:lnTo>
+                <a:close/>
+              </a:path>
+            </a:pathLst>
+          </a:custGeom>
+          <a:gradFill>
+            <a:gsLst>
+              <a:gs pos="0">
+                <a:srgbClr val="FFAA00"/>
+              </a:gs>
+              <a:gs pos="100000">
+                <a:srgbClr val="AA00FF"/>
+              </a:gs>
+            </a:gsLst>
+            <a:lin ang="5400000"/>
+          </a:gradFill>
+          <a:ln w="19050">
+            <a:solidFill>
+              <a:srgbClr val="222222"/>
+            </a:solidFill>
+            <a:headEnd type="triangle"/>
+            <a:tailEnd type="diamond"/>
+          </a:ln>
+          <a:effectLst>
+            <a:outerShdw blurRad="63500" dist="63500" dir="2700000">
+              <a:srgbClr val="333333">
+                <a:alpha val="50000"/>
+              </a:srgbClr>
+            </a:outerShdw>
+          </a:effectLst>
         </p:spPr>
       </p:sp>
       <p:graphicFrame>

</xml_diff>

<commit_message>
Complete PowerPoint text fidelity tracker
</commit_message>
<xml_diff>
--- a/fixtures/render/basic.pptx
+++ b/fixtures/render/basic.pptx
@@ -4,6 +4,7 @@
   <p:sldIdLst>
     <p:sldId id="256" r:id="rId1"/>
     <p:sldId id="257" r:id="rId2"/>
+    <p:sldId id="258" r:id="rId3"/>
   </p:sldIdLst>
   <p:sldSz cx="12192000" cy="6858000"/>
 </p:presentation>
@@ -427,6 +428,240 @@
 </p:sld>
 </file>
 
+<file path=ppt/slides/slide3.xml><?xml version="1.0" encoding="utf-8"?>
+<p:sld xmlns:p="http://schemas.openxmlformats.org/presentationml/2006/main" xmlns:a="http://schemas.openxmlformats.org/drawingml/2006/main">
+  <p:cSld>
+    <p:spTree>
+      <p:sp>
+        <p:nvSpPr>
+          <p:cNvPr id="2" name="Shape AutoFit"/>
+        </p:nvSpPr>
+        <p:spPr>
+          <a:xfrm>
+            <a:off x="400000" y="300000"/>
+            <a:ext cx="3400000" cy="900000"/>
+          </a:xfrm>
+          <a:prstGeom prst="roundRect"/>
+          <a:solidFill>
+            <a:srgbClr val="EAF2F8"/>
+          </a:solidFill>
+        </p:spPr>
+        <p:txBody>
+          <a:bodyPr lIns="120000" tIns="80000" rIns="120000" bIns="80000">
+            <a:spAutoFit/>
+          </a:bodyPr>
+          <a:p>
+            <a:r>
+              <a:rPr sz="1800" b="1">
+                <a:latin typeface="Arial"/>
+              </a:rPr>
+              <a:t>Shape resize keeps this type size while the box grows.</a:t>
+            </a:r>
+          </a:p>
+        </p:txBody>
+      </p:sp>
+      <p:sp>
+        <p:nvSpPr>
+          <p:cNvPr id="3" name="Normal AutoFit"/>
+        </p:nvSpPr>
+        <p:spPr>
+          <a:xfrm>
+            <a:off x="4200000" y="300000"/>
+            <a:ext cx="3400000" cy="900000"/>
+          </a:xfrm>
+          <a:prstGeom prst="rect"/>
+          <a:solidFill>
+            <a:srgbClr val="FDEBD0"/>
+          </a:solidFill>
+        </p:spPr>
+        <p:txBody>
+          <a:bodyPr>
+            <a:normAutofit fontScale="80000" lnSpcReduction="15000"/>
+          </a:bodyPr>
+          <a:p>
+            <a:r>
+              <a:rPr sz="2200">
+                <a:latin typeface="Arial"/>
+              </a:rPr>
+              <a:t>Normal AutoFit honors authored scale and spacing reduction.</a:t>
+            </a:r>
+          </a:p>
+        </p:txBody>
+      </p:sp>
+      <p:sp>
+        <p:nvSpPr>
+          <p:cNvPr id="4" name="Unicode wrapping"/>
+        </p:nvSpPr>
+        <p:spPr>
+          <a:xfrm>
+            <a:off x="8000000" y="300000"/>
+            <a:ext cx="3700000" cy="900000"/>
+          </a:xfrm>
+          <a:prstGeom prst="rect"/>
+          <a:solidFill>
+            <a:srgbClr val="E8F8F5"/>
+          </a:solidFill>
+        </p:spPr>
+        <p:txBody>
+          <a:bodyPr/>
+          <a:p>
+            <a:r>
+              <a:rPr sz="1600">
+                <a:ea typeface="Arial"/>
+              </a:rPr>
+              <a:t>「日本語」、한글 👨🏽‍💻 A B ภาษาไทย</a:t>
+            </a:r>
+          </a:p>
+        </p:txBody>
+      </p:sp>
+      <p:sp>
+        <p:nvSpPr>
+          <p:cNvPr id="5" name="Paragraph metrics and bullets"/>
+        </p:nvSpPr>
+        <p:spPr>
+          <a:xfrm>
+            <a:off x="400000" y="1700000"/>
+            <a:ext cx="5200000" cy="2200000"/>
+          </a:xfrm>
+          <a:prstGeom prst="rect"/>
+          <a:solidFill>
+            <a:srgbClr val="F8F9F9"/>
+          </a:solidFill>
+        </p:spPr>
+        <p:txBody>
+          <a:bodyPr defTabSz="600000"/>
+          <a:p>
+            <a:pPr marL="500000" indent="-250000">
+              <a:buAutoNum type="alphaLcParenR" startAt="2"/>
+              <a:lnSpc>
+                <a:spcPct val="115000"/>
+              </a:lnSpc>
+            </a:pPr>
+            <a:r>
+              <a:rPr sz="1500"/>
+              <a:t>Hanging numbered item with mixed </a:t>
+            </a:r>
+            <a:r>
+              <a:rPr sz="2100" b="1"/>
+              <a:t>metrics</a:t>
+            </a:r>
+          </a:p>
+          <a:p>
+            <a:pPr marL="500000" indent="-250000">
+              <a:buAutoNum type="alphaLcParenR"/>
+            </a:pPr>
+            <a:r>
+              <a:rPr sz="1500"/>
+              <a:t>continued numbering</a:t>
+            </a:r>
+          </a:p>
+          <a:p>
+            <a:endParaRPr sz="1200"/>
+          </a:p>
+          <a:p>
+            <a:pPr>
+              <a:tabLst>
+                <a:tab pos="1800000" algn="r"/>
+              </a:tabLst>
+            </a:pPr>
+            <a:r>
+              <a:rPr sz="1400"/>
+              <a:t>Label	42.5</a:t>
+            </a:r>
+          </a:p>
+        </p:txBody>
+      </p:sp>
+      <p:sp>
+        <p:nvSpPr>
+          <p:cNvPr id="6" name="Three columns"/>
+        </p:nvSpPr>
+        <p:spPr>
+          <a:xfrm>
+            <a:off x="6000000" y="1700000"/>
+            <a:ext cx="5700000" cy="2200000"/>
+          </a:xfrm>
+          <a:prstGeom prst="rect"/>
+          <a:solidFill>
+            <a:srgbClr val="F4ECF7"/>
+          </a:solidFill>
+        </p:spPr>
+        <p:txBody>
+          <a:bodyPr numCol="3" spcCol="160000"/>
+          <a:p>
+            <a:r>
+              <a:rPr sz="1300"/>
+              <a:t>Column one line one. Column one line two. Column two follows when height is exhausted. Column three preserves source order and mappings.</a:t>
+            </a:r>
+          </a:p>
+        </p:txBody>
+      </p:sp>
+      <p:sp>
+        <p:nvSpPr>
+          <p:cNvPr id="7" name="2D text effects"/>
+        </p:nvSpPr>
+        <p:spPr>
+          <a:xfrm>
+            <a:off x="400000" y="4400000"/>
+            <a:ext cx="11300000" cy="1700000"/>
+          </a:xfrm>
+          <a:prstGeom prst="rect"/>
+          <a:noFill/>
+        </p:spPr>
+        <p:txBody>
+          <a:bodyPr>
+            <a:prstTxWarp prst="textWave1">
+              <a:avLst>
+                <a:gd name="adj" fmla="val 30000"/>
+              </a:avLst>
+            </a:prstTxWarp>
+          </a:bodyPr>
+          <a:p>
+            <a:pPr algn="ctr"/>
+            <a:r>
+              <a:rPr sz="3200" b="1">
+                <a:gradFill>
+                  <a:gsLst>
+                    <a:gs pos="0">
+                      <a:srgbClr val="1F618D"/>
+                    </a:gs>
+                    <a:gs pos="100000">
+                      <a:srgbClr val="AF7AC5"/>
+                    </a:gs>
+                  </a:gsLst>
+                  <a:lin ang="0"/>
+                </a:gradFill>
+                <a:ln w="19050">
+                  <a:solidFill>
+                    <a:srgbClr val="17202A"/>
+                  </a:solidFill>
+                </a:ln>
+                <a:effectLst>
+                  <a:outerShdw blurRad="50000" dist="30000" dir="2700000">
+                    <a:srgbClr val="000000">
+                      <a:alpha val="40000"/>
+                    </a:srgbClr>
+                  </a:outerShdw>
+                  <a:innerShdw blurRad="25000" dist="15000" dir="8100000">
+                    <a:srgbClr val="FFFFFF">
+                      <a:alpha val="50000"/>
+                    </a:srgbClr>
+                  </a:innerShdw>
+                  <a:glow rad="45000">
+                    <a:srgbClr val="5DADE2"/>
+                  </a:glow>
+                  <a:reflection/>
+                </a:effectLst>
+              </a:rPr>
+              <a:t>Editable 2D WordArt effects</a:t>
+            </a:r>
+          </a:p>
+        </p:txBody>
+      </p:sp>
+    </p:spTree>
+  </p:cSld>
+</p:sld>
+</file>
+
 <file path=ppt/theme/theme1.xml><?xml version="1.0" encoding="utf-8"?>
 <a:theme xmlns:a="http://schemas.openxmlformats.org/drawingml/2006/main">
   <a:themeElements>

</xml_diff>

<commit_message>
Complete high-impact PowerPoint text fidelity (#62)
* Implement WPDL v7 text fidelity pipeline

* Complete PowerPoint text fidelity tracker

* Allow ordinal suffix in spell check

* Replace unmaintained text shaper
</commit_message>
<xml_diff>
--- a/fixtures/render/basic.pptx
+++ b/fixtures/render/basic.pptx
@@ -4,6 +4,7 @@
   <p:sldIdLst>
     <p:sldId id="256" r:id="rId1"/>
     <p:sldId id="257" r:id="rId2"/>
+    <p:sldId id="258" r:id="rId3"/>
   </p:sldIdLst>
   <p:sldSz cx="12192000" cy="6858000"/>
 </p:presentation>
@@ -427,6 +428,240 @@
 </p:sld>
 </file>
 
+<file path=ppt/slides/slide3.xml><?xml version="1.0" encoding="utf-8"?>
+<p:sld xmlns:p="http://schemas.openxmlformats.org/presentationml/2006/main" xmlns:a="http://schemas.openxmlformats.org/drawingml/2006/main">
+  <p:cSld>
+    <p:spTree>
+      <p:sp>
+        <p:nvSpPr>
+          <p:cNvPr id="2" name="Shape AutoFit"/>
+        </p:nvSpPr>
+        <p:spPr>
+          <a:xfrm>
+            <a:off x="400000" y="300000"/>
+            <a:ext cx="3400000" cy="900000"/>
+          </a:xfrm>
+          <a:prstGeom prst="roundRect"/>
+          <a:solidFill>
+            <a:srgbClr val="EAF2F8"/>
+          </a:solidFill>
+        </p:spPr>
+        <p:txBody>
+          <a:bodyPr lIns="120000" tIns="80000" rIns="120000" bIns="80000">
+            <a:spAutoFit/>
+          </a:bodyPr>
+          <a:p>
+            <a:r>
+              <a:rPr sz="1800" b="1">
+                <a:latin typeface="Arial"/>
+              </a:rPr>
+              <a:t>Shape resize keeps this type size while the box grows.</a:t>
+            </a:r>
+          </a:p>
+        </p:txBody>
+      </p:sp>
+      <p:sp>
+        <p:nvSpPr>
+          <p:cNvPr id="3" name="Normal AutoFit"/>
+        </p:nvSpPr>
+        <p:spPr>
+          <a:xfrm>
+            <a:off x="4200000" y="300000"/>
+            <a:ext cx="3400000" cy="900000"/>
+          </a:xfrm>
+          <a:prstGeom prst="rect"/>
+          <a:solidFill>
+            <a:srgbClr val="FDEBD0"/>
+          </a:solidFill>
+        </p:spPr>
+        <p:txBody>
+          <a:bodyPr>
+            <a:normAutofit fontScale="80000" lnSpcReduction="15000"/>
+          </a:bodyPr>
+          <a:p>
+            <a:r>
+              <a:rPr sz="2200">
+                <a:latin typeface="Arial"/>
+              </a:rPr>
+              <a:t>Normal AutoFit honors authored scale and spacing reduction.</a:t>
+            </a:r>
+          </a:p>
+        </p:txBody>
+      </p:sp>
+      <p:sp>
+        <p:nvSpPr>
+          <p:cNvPr id="4" name="Unicode wrapping"/>
+        </p:nvSpPr>
+        <p:spPr>
+          <a:xfrm>
+            <a:off x="8000000" y="300000"/>
+            <a:ext cx="3700000" cy="900000"/>
+          </a:xfrm>
+          <a:prstGeom prst="rect"/>
+          <a:solidFill>
+            <a:srgbClr val="E8F8F5"/>
+          </a:solidFill>
+        </p:spPr>
+        <p:txBody>
+          <a:bodyPr/>
+          <a:p>
+            <a:r>
+              <a:rPr sz="1600">
+                <a:ea typeface="Arial"/>
+              </a:rPr>
+              <a:t>「日本語」、한글 👨🏽‍💻 A B ภาษาไทย</a:t>
+            </a:r>
+          </a:p>
+        </p:txBody>
+      </p:sp>
+      <p:sp>
+        <p:nvSpPr>
+          <p:cNvPr id="5" name="Paragraph metrics and bullets"/>
+        </p:nvSpPr>
+        <p:spPr>
+          <a:xfrm>
+            <a:off x="400000" y="1700000"/>
+            <a:ext cx="5200000" cy="2200000"/>
+          </a:xfrm>
+          <a:prstGeom prst="rect"/>
+          <a:solidFill>
+            <a:srgbClr val="F8F9F9"/>
+          </a:solidFill>
+        </p:spPr>
+        <p:txBody>
+          <a:bodyPr defTabSz="600000"/>
+          <a:p>
+            <a:pPr marL="500000" indent="-250000">
+              <a:buAutoNum type="alphaLcParenR" startAt="2"/>
+              <a:lnSpc>
+                <a:spcPct val="115000"/>
+              </a:lnSpc>
+            </a:pPr>
+            <a:r>
+              <a:rPr sz="1500"/>
+              <a:t>Hanging numbered item with mixed </a:t>
+            </a:r>
+            <a:r>
+              <a:rPr sz="2100" b="1"/>
+              <a:t>metrics</a:t>
+            </a:r>
+          </a:p>
+          <a:p>
+            <a:pPr marL="500000" indent="-250000">
+              <a:buAutoNum type="alphaLcParenR"/>
+            </a:pPr>
+            <a:r>
+              <a:rPr sz="1500"/>
+              <a:t>continued numbering</a:t>
+            </a:r>
+          </a:p>
+          <a:p>
+            <a:endParaRPr sz="1200"/>
+          </a:p>
+          <a:p>
+            <a:pPr>
+              <a:tabLst>
+                <a:tab pos="1800000" algn="r"/>
+              </a:tabLst>
+            </a:pPr>
+            <a:r>
+              <a:rPr sz="1400"/>
+              <a:t>Label	42.5</a:t>
+            </a:r>
+          </a:p>
+        </p:txBody>
+      </p:sp>
+      <p:sp>
+        <p:nvSpPr>
+          <p:cNvPr id="6" name="Three columns"/>
+        </p:nvSpPr>
+        <p:spPr>
+          <a:xfrm>
+            <a:off x="6000000" y="1700000"/>
+            <a:ext cx="5700000" cy="2200000"/>
+          </a:xfrm>
+          <a:prstGeom prst="rect"/>
+          <a:solidFill>
+            <a:srgbClr val="F4ECF7"/>
+          </a:solidFill>
+        </p:spPr>
+        <p:txBody>
+          <a:bodyPr numCol="3" spcCol="160000"/>
+          <a:p>
+            <a:r>
+              <a:rPr sz="1300"/>
+              <a:t>Column one line one. Column one line two. Column two follows when height is exhausted. Column three preserves source order and mappings.</a:t>
+            </a:r>
+          </a:p>
+        </p:txBody>
+      </p:sp>
+      <p:sp>
+        <p:nvSpPr>
+          <p:cNvPr id="7" name="2D text effects"/>
+        </p:nvSpPr>
+        <p:spPr>
+          <a:xfrm>
+            <a:off x="400000" y="4400000"/>
+            <a:ext cx="11300000" cy="1700000"/>
+          </a:xfrm>
+          <a:prstGeom prst="rect"/>
+          <a:noFill/>
+        </p:spPr>
+        <p:txBody>
+          <a:bodyPr>
+            <a:prstTxWarp prst="textWave1">
+              <a:avLst>
+                <a:gd name="adj" fmla="val 30000"/>
+              </a:avLst>
+            </a:prstTxWarp>
+          </a:bodyPr>
+          <a:p>
+            <a:pPr algn="ctr"/>
+            <a:r>
+              <a:rPr sz="3200" b="1">
+                <a:gradFill>
+                  <a:gsLst>
+                    <a:gs pos="0">
+                      <a:srgbClr val="1F618D"/>
+                    </a:gs>
+                    <a:gs pos="100000">
+                      <a:srgbClr val="AF7AC5"/>
+                    </a:gs>
+                  </a:gsLst>
+                  <a:lin ang="0"/>
+                </a:gradFill>
+                <a:ln w="19050">
+                  <a:solidFill>
+                    <a:srgbClr val="17202A"/>
+                  </a:solidFill>
+                </a:ln>
+                <a:effectLst>
+                  <a:outerShdw blurRad="50000" dist="30000" dir="2700000">
+                    <a:srgbClr val="000000">
+                      <a:alpha val="40000"/>
+                    </a:srgbClr>
+                  </a:outerShdw>
+                  <a:innerShdw blurRad="25000" dist="15000" dir="8100000">
+                    <a:srgbClr val="FFFFFF">
+                      <a:alpha val="50000"/>
+                    </a:srgbClr>
+                  </a:innerShdw>
+                  <a:glow rad="45000">
+                    <a:srgbClr val="5DADE2"/>
+                  </a:glow>
+                  <a:reflection/>
+                </a:effectLst>
+              </a:rPr>
+              <a:t>Editable 2D WordArt effects</a:t>
+            </a:r>
+          </a:p>
+        </p:txBody>
+      </p:sp>
+    </p:spTree>
+  </p:cSld>
+</p:sld>
+</file>
+
 <file path=ppt/theme/theme1.xml><?xml version="1.0" encoding="utf-8"?>
 <a:theme xmlns:a="http://schemas.openxmlformats.org/drawingml/2006/main">
   <a:themeElements>

</xml_diff>

<commit_message>
Render associated SmartArt fallback images
</commit_message>
<xml_diff>
--- a/fixtures/render/basic.pptx
+++ b/fixtures/render/basic.pptx
@@ -71,6 +71,24 @@
 </c:chartSpace>
 </file>
 
+<file path=ppt/diagrams/data1.xml><?xml version="1.0" encoding="utf-8"?>
+<dgm:dataModel xmlns:dgm="http://schemas.openxmlformats.org/drawingml/2006/diagram" xmlns:r="http://schemas.openxmlformats.org/officeDocument/2006/relationships">
+  <dgm:ptLst/>
+  <dgm:cxnLst/>
+  <dgm:extLst>
+    <dgm:ext uri="urn:wasmppt:opaque-smartart-extension">
+      <future:payload xmlns:future="urn:wasmppt:future">preserve exactly</future:payload>
+    </dgm:ext>
+  </dgm:extLst>
+</dgm:dataModel>
+</file>
+
+<file path=ppt/diagrams/drawing1.xml><?xml version="1.0" encoding="utf-8"?>
+<dsp:drawing xmlns:dsp="http://schemas.microsoft.com/office/drawing/2008/diagram">
+  <dsp:spTree future="preserve"/>
+</dsp:drawing>
+</file>
+
 <file path=ppt/slideLayouts/slideLayout1.xml><?xml version="1.0" encoding="utf-8"?>
 <p:sldLayout xmlns:p="http://schemas.openxmlformats.org/presentationml/2006/main" xmlns:a="http://schemas.openxmlformats.org/drawingml/2006/main">
   <p:cSld>
@@ -298,7 +316,7 @@
 </file>
 
 <file path=ppt/slides/slide2.xml><?xml version="1.0" encoding="utf-8"?>
-<p:sld xmlns:p="http://schemas.openxmlformats.org/presentationml/2006/main" xmlns:a="http://schemas.openxmlformats.org/drawingml/2006/main" xmlns:c="http://schemas.openxmlformats.org/drawingml/2006/chart" xmlns:dgm="http://schemas.openxmlformats.org/drawingml/2006/diagram" xmlns:r="http://schemas.openxmlformats.org/officeDocument/2006/relationships">
+<p:sld xmlns:p="http://schemas.openxmlformats.org/presentationml/2006/main" xmlns:a="http://schemas.openxmlformats.org/drawingml/2006/main" xmlns:c="http://schemas.openxmlformats.org/drawingml/2006/chart" xmlns:dgm="http://schemas.openxmlformats.org/drawingml/2006/diagram" xmlns:r="http://schemas.openxmlformats.org/officeDocument/2006/relationships" xmlns:mc="http://schemas.openxmlformats.org/markup-compatibility/2006">
   <p:cSld>
     <p:spTree>
       <p:sp>
@@ -395,16 +413,41 @@
           </a:graphicData>
         </a:graphic>
       </p:graphicFrame>
-      <p:graphicFrame>
-        <p:nvGraphicFramePr>
-          <p:cNvPr id="8" name="SmartArt"/>
-        </p:nvGraphicFramePr>
-        <a:graphic>
-          <a:graphicData uri="http://schemas.openxmlformats.org/drawingml/2006/diagram">
-            <dgm:relIds r:dm="rDiagram"/>
-          </a:graphicData>
-        </a:graphic>
-      </p:graphicFrame>
+      <mc:AlternateContent>
+        <mc:Choice Requires="dgm">
+          <p:graphicFrame>
+            <p:nvGraphicFramePr>
+              <p:cNvPr id="8" name="SmartArt" descr="SmartArt process preview"/>
+            </p:nvGraphicFramePr>
+            <p:xfrm>
+              <a:off x="5600000" y="4300000"/>
+              <a:ext cx="2500000" cy="1800000"/>
+            </p:xfrm>
+            <a:graphic>
+              <a:graphicData uri="http://schemas.openxmlformats.org/drawingml/2006/diagram">
+                <dgm:relIds r:dm="rDiagram"/>
+              </a:graphicData>
+            </a:graphic>
+          </p:graphicFrame>
+        </mc:Choice>
+        <mc:Fallback>
+          <p:pic>
+            <p:nvPicPr>
+              <p:cNvPr id="80" name="SmartArt preview image"/>
+            </p:nvPicPr>
+            <p:blipFill>
+              <a:blip r:embed="rSmartArtPreview"/>
+              <a:srcRect l="1000" t="2000" r="3000" b="4000"/>
+            </p:blipFill>
+            <p:spPr>
+              <a:xfrm>
+                <a:off x="5600000" y="4300000"/>
+                <a:ext cx="2500000" cy="1800000"/>
+              </a:xfrm>
+            </p:spPr>
+          </p:pic>
+        </mc:Fallback>
+      </mc:AlternateContent>
       <p:pic>
         <p:nvPicPr>
           <p:cNvPr id="9" name="Metafile"/>

</xml_diff>